<commit_message>
ppt layout changed but not the ui
</commit_message>
<xml_diff>
--- a/output/demo_java21_spring/demo_java21_spring.pptx
+++ b/output/demo_java21_spring/demo_java21_spring.pptx
@@ -3124,8 +3124,8 @@
         </p:nvSpPr>
         <p:spPr>
           <a:xfrm>
-            <a:off x="1981199" y="1174750"/>
-            <a:ext cx="8229599" cy="425449"/>
+            <a:off x="1981199" y="1168400"/>
+            <a:ext cx="8229599" cy="438149"/>
           </a:xfrm>
           <a:prstGeom prst="rect">
             <a:avLst/>
@@ -3141,7 +3141,7 @@
             <a:pPr algn="l">
               <a:defRPr sz="4400" b="1">
                 <a:solidFill>
-                  <a:srgbClr val="425C80"/>
+                  <a:srgbClr val="1E2653"/>
                 </a:solidFill>
                 <a:latin typeface="Arial"/>
               </a:defRPr>
@@ -3161,17 +3161,17 @@
         <p:spPr>
           <a:xfrm>
             <a:off x="2235199" y="5454650"/>
-            <a:ext cx="7721599" cy="323849"/>
+            <a:ext cx="7721599" cy="330200"/>
           </a:xfrm>
           <a:prstGeom prst="roundRect">
             <a:avLst/>
           </a:prstGeom>
           <a:solidFill>
-            <a:srgbClr val="6E9AD6"/>
+            <a:srgbClr val="FFFFFF"/>
           </a:solidFill>
           <a:ln w="19050">
             <a:solidFill>
-              <a:srgbClr val="425C80"/>
+              <a:srgbClr val="2563EB"/>
             </a:solidFill>
           </a:ln>
         </p:spPr>
@@ -3196,7 +3196,7 @@
             <a:pPr algn="ctr">
               <a:defRPr sz="3000" b="1">
                 <a:solidFill>
-                  <a:srgbClr val="FFFFFF"/>
+                  <a:srgbClr val="1E2653"/>
                 </a:solidFill>
                 <a:latin typeface="Segoe UI"/>
               </a:defRPr>
@@ -3215,18 +3215,18 @@
         </p:nvSpPr>
         <p:spPr>
           <a:xfrm>
-            <a:off x="2235199" y="1904999"/>
-            <a:ext cx="7721599" cy="806450"/>
+            <a:off x="2235199" y="1911350"/>
+            <a:ext cx="7721599" cy="825499"/>
           </a:xfrm>
           <a:prstGeom prst="roundRect">
             <a:avLst/>
           </a:prstGeom>
           <a:solidFill>
-            <a:srgbClr val="FFFFFF"/>
+            <a:srgbClr val="F8FAFC"/>
           </a:solidFill>
           <a:ln w="12700">
             <a:solidFill>
-              <a:srgbClr val="6E9AD6"/>
+              <a:srgbClr val="E2E8F0"/>
             </a:solidFill>
           </a:ln>
         </p:spPr>
@@ -3254,7 +3254,7 @@
               </a:spcAft>
               <a:defRPr sz="3000">
                 <a:solidFill>
-                  <a:srgbClr val="0F172A"/>
+                  <a:srgbClr val="1E293B"/>
                 </a:solidFill>
                 <a:latin typeface="Segoe UI"/>
               </a:defRPr>
@@ -3270,7 +3270,7 @@
               </a:spcAft>
               <a:defRPr sz="3000">
                 <a:solidFill>
-                  <a:srgbClr val="0F172A"/>
+                  <a:srgbClr val="1E293B"/>
                 </a:solidFill>
                 <a:latin typeface="Segoe UI"/>
               </a:defRPr>
@@ -3286,7 +3286,7 @@
               </a:spcAft>
               <a:defRPr sz="3000">
                 <a:solidFill>
-                  <a:srgbClr val="0F172A"/>
+                  <a:srgbClr val="1E293B"/>
                 </a:solidFill>
                 <a:latin typeface="Segoe UI"/>
               </a:defRPr>
@@ -3347,8 +3347,8 @@
         </p:nvSpPr>
         <p:spPr>
           <a:xfrm>
-            <a:off x="1981199" y="1174750"/>
-            <a:ext cx="8229599" cy="425449"/>
+            <a:off x="1981199" y="1168400"/>
+            <a:ext cx="8229599" cy="438149"/>
           </a:xfrm>
           <a:prstGeom prst="rect">
             <a:avLst/>
@@ -3364,7 +3364,7 @@
             <a:pPr algn="l">
               <a:defRPr sz="4400" b="1">
                 <a:solidFill>
-                  <a:srgbClr val="425C80"/>
+                  <a:srgbClr val="1E2653"/>
                 </a:solidFill>
                 <a:latin typeface="Arial"/>
               </a:defRPr>
@@ -3398,7 +3398,7 @@
           <a:lstStyle/>
           <a:p>
             <a:pPr algn="l">
-              <a:defRPr sz="1300">
+              <a:defRPr sz="1200">
                 <a:solidFill>
                   <a:srgbClr val="64748B"/>
                 </a:solidFill>
@@ -3419,18 +3419,18 @@
         </p:nvSpPr>
         <p:spPr>
           <a:xfrm>
-            <a:off x="1981199" y="1778000"/>
-            <a:ext cx="3994149" cy="838200"/>
+            <a:off x="1981199" y="1784350"/>
+            <a:ext cx="3505199" cy="2159000"/>
           </a:xfrm>
           <a:prstGeom prst="roundRect">
             <a:avLst/>
           </a:prstGeom>
           <a:solidFill>
-            <a:srgbClr val="FFFFFF"/>
+            <a:srgbClr val="F8FAFC"/>
           </a:solidFill>
           <a:ln w="12700">
             <a:solidFill>
-              <a:srgbClr val="6E9AD6"/>
+              <a:srgbClr val="E2E8F0"/>
             </a:solidFill>
           </a:ln>
         </p:spPr>
@@ -3458,7 +3458,7 @@
               </a:spcAft>
               <a:defRPr sz="3000">
                 <a:solidFill>
-                  <a:srgbClr val="0F172A"/>
+                  <a:srgbClr val="1E293B"/>
                 </a:solidFill>
                 <a:latin typeface="Segoe UI"/>
               </a:defRPr>
@@ -3474,7 +3474,7 @@
               </a:spcAft>
               <a:defRPr sz="3000">
                 <a:solidFill>
-                  <a:srgbClr val="0F172A"/>
+                  <a:srgbClr val="1E293B"/>
                 </a:solidFill>
                 <a:latin typeface="Segoe UI"/>
               </a:defRPr>
@@ -3490,7 +3490,7 @@
               </a:spcAft>
               <a:defRPr sz="3000">
                 <a:solidFill>
-                  <a:srgbClr val="0F172A"/>
+                  <a:srgbClr val="1E293B"/>
                 </a:solidFill>
                 <a:latin typeface="Segoe UI"/>
               </a:defRPr>
@@ -3509,18 +3509,18 @@
         </p:nvSpPr>
         <p:spPr>
           <a:xfrm>
-            <a:off x="6216649" y="1778000"/>
-            <a:ext cx="3994149" cy="1765299"/>
+            <a:off x="5740399" y="1784350"/>
+            <a:ext cx="4470399" cy="2159000"/>
           </a:xfrm>
           <a:prstGeom prst="roundRect">
             <a:avLst/>
           </a:prstGeom>
           <a:solidFill>
-            <a:srgbClr val="1E1E2E"/>
+            <a:srgbClr val="0F172A"/>
           </a:solidFill>
-          <a:ln w="19050">
+          <a:ln w="12700">
             <a:solidFill>
-              <a:srgbClr val="6E9AD6"/>
+              <a:srgbClr val="1E293B"/>
             </a:solidFill>
           </a:ln>
         </p:spPr>
@@ -3546,9 +3546,9 @@
               <a:spcAft>
                 <a:spcPts val="800"/>
               </a:spcAft>
-              <a:defRPr sz="1300">
-                <a:solidFill>
-                  <a:srgbClr val="8C9BAF"/>
+              <a:defRPr sz="1200">
+                <a:solidFill>
+                  <a:srgbClr val="60A5FA"/>
                 </a:solidFill>
                 <a:latin typeface="Consolas"/>
               </a:defRPr>
@@ -3562,12 +3562,12 @@
               <a:spcAft>
                 <a:spcPts val="200"/>
               </a:spcAft>
-              <a:defRPr sz="2000">
+              <a:defRPr sz="1900">
                 <a:latin typeface="Consolas"/>
               </a:defRPr>
             </a:pPr>
             <a:r>
-              <a:rPr sz="2000">
+              <a:rPr sz="1900">
                 <a:solidFill>
                   <a:srgbClr val="C678DD"/>
                 </a:solidFill>
@@ -3576,7 +3576,7 @@
               <a:t>public</a:t>
             </a:r>
             <a:r>
-              <a:rPr sz="2000">
+              <a:rPr sz="1900">
                 <a:solidFill>
                   <a:srgbClr val="F0F4FA"/>
                 </a:solidFill>
@@ -3585,7 +3585,7 @@
               <a:t> </a:t>
             </a:r>
             <a:r>
-              <a:rPr sz="2000">
+              <a:rPr sz="1900">
                 <a:solidFill>
                   <a:srgbClr val="C678DD"/>
                 </a:solidFill>
@@ -3594,7 +3594,7 @@
               <a:t>class</a:t>
             </a:r>
             <a:r>
-              <a:rPr sz="2000">
+              <a:rPr sz="1900">
                 <a:solidFill>
                   <a:srgbClr val="F0F4FA"/>
                 </a:solidFill>
@@ -3603,7 +3603,7 @@
               <a:t> </a:t>
             </a:r>
             <a:r>
-              <a:rPr sz="2000">
+              <a:rPr sz="1900">
                 <a:solidFill>
                   <a:srgbClr val="E5C07B"/>
                 </a:solidFill>
@@ -3612,7 +3612,7 @@
               <a:t>Solution</a:t>
             </a:r>
             <a:r>
-              <a:rPr sz="2000">
+              <a:rPr sz="1900">
                 <a:solidFill>
                   <a:srgbClr val="F0F4FA"/>
                 </a:solidFill>
@@ -3621,7 +3621,7 @@
               <a:t> </a:t>
             </a:r>
             <a:r>
-              <a:rPr sz="2000">
+              <a:rPr sz="1900">
                 <a:solidFill>
                   <a:srgbClr val="ABB2BF"/>
                 </a:solidFill>
@@ -3635,12 +3635,12 @@
               <a:spcAft>
                 <a:spcPts val="200"/>
               </a:spcAft>
-              <a:defRPr sz="2000">
+              <a:defRPr sz="1900">
                 <a:latin typeface="Consolas"/>
               </a:defRPr>
             </a:pPr>
             <a:r>
-              <a:rPr sz="2000">
+              <a:rPr sz="1900">
                 <a:solidFill>
                   <a:srgbClr val="C678DD"/>
                 </a:solidFill>
@@ -3649,7 +3649,7 @@
               <a:t>public</a:t>
             </a:r>
             <a:r>
-              <a:rPr sz="2000">
+              <a:rPr sz="1900">
                 <a:solidFill>
                   <a:srgbClr val="F0F4FA"/>
                 </a:solidFill>
@@ -3658,7 +3658,7 @@
               <a:t> </a:t>
             </a:r>
             <a:r>
-              <a:rPr sz="2000">
+              <a:rPr sz="1900">
                 <a:solidFill>
                   <a:srgbClr val="C678DD"/>
                 </a:solidFill>
@@ -3667,7 +3667,7 @@
               <a:t>static</a:t>
             </a:r>
             <a:r>
-              <a:rPr sz="2000">
+              <a:rPr sz="1900">
                 <a:solidFill>
                   <a:srgbClr val="F0F4FA"/>
                 </a:solidFill>
@@ -3676,7 +3676,7 @@
               <a:t> </a:t>
             </a:r>
             <a:r>
-              <a:rPr sz="2000">
+              <a:rPr sz="1900">
                 <a:solidFill>
                   <a:srgbClr val="C678DD"/>
                 </a:solidFill>
@@ -3685,7 +3685,7 @@
               <a:t>void</a:t>
             </a:r>
             <a:r>
-              <a:rPr sz="2000">
+              <a:rPr sz="1900">
                 <a:solidFill>
                   <a:srgbClr val="F0F4FA"/>
                 </a:solidFill>
@@ -3694,7 +3694,7 @@
               <a:t> </a:t>
             </a:r>
             <a:r>
-              <a:rPr sz="2000">
+              <a:rPr sz="1900">
                 <a:solidFill>
                   <a:srgbClr val="61AFEF"/>
                 </a:solidFill>
@@ -3703,7 +3703,7 @@
               <a:t>main</a:t>
             </a:r>
             <a:r>
-              <a:rPr sz="2000">
+              <a:rPr sz="1900">
                 <a:solidFill>
                   <a:srgbClr val="ABB2BF"/>
                 </a:solidFill>
@@ -3712,7 +3712,7 @@
               <a:t>(</a:t>
             </a:r>
             <a:r>
-              <a:rPr sz="2000">
+              <a:rPr sz="1900">
                 <a:solidFill>
                   <a:srgbClr val="F0F4FA"/>
                 </a:solidFill>
@@ -3721,7 +3721,7 @@
               <a:t>String</a:t>
             </a:r>
             <a:r>
-              <a:rPr sz="2000">
+              <a:rPr sz="1900">
                 <a:solidFill>
                   <a:srgbClr val="56B6C2"/>
                 </a:solidFill>
@@ -3730,7 +3730,7 @@
               <a:t>[</a:t>
             </a:r>
             <a:r>
-              <a:rPr sz="2000">
+              <a:rPr sz="1900">
                 <a:solidFill>
                   <a:srgbClr val="56B6C2"/>
                 </a:solidFill>
@@ -3739,7 +3739,7 @@
               <a:t>]</a:t>
             </a:r>
             <a:r>
-              <a:rPr sz="2000">
+              <a:rPr sz="1900">
                 <a:solidFill>
                   <a:srgbClr val="F0F4FA"/>
                 </a:solidFill>
@@ -3748,7 +3748,7 @@
               <a:t> </a:t>
             </a:r>
             <a:r>
-              <a:rPr sz="2000">
+              <a:rPr sz="1900">
                 <a:solidFill>
                   <a:srgbClr val="F0F4FA"/>
                 </a:solidFill>
@@ -3757,7 +3757,7 @@
               <a:t>args</a:t>
             </a:r>
             <a:r>
-              <a:rPr sz="2000">
+              <a:rPr sz="1900">
                 <a:solidFill>
                   <a:srgbClr val="ABB2BF"/>
                 </a:solidFill>
@@ -3766,7 +3766,7 @@
               <a:t>)</a:t>
             </a:r>
             <a:r>
-              <a:rPr sz="2000">
+              <a:rPr sz="1900">
                 <a:solidFill>
                   <a:srgbClr val="F0F4FA"/>
                 </a:solidFill>
@@ -3775,7 +3775,7 @@
               <a:t> </a:t>
             </a:r>
             <a:r>
-              <a:rPr sz="2000">
+              <a:rPr sz="1900">
                 <a:solidFill>
                   <a:srgbClr val="C678DD"/>
                 </a:solidFill>
@@ -3784,7 +3784,7 @@
               <a:t>throws</a:t>
             </a:r>
             <a:r>
-              <a:rPr sz="2000">
+              <a:rPr sz="1900">
                 <a:solidFill>
                   <a:srgbClr val="F0F4FA"/>
                 </a:solidFill>
@@ -3793,7 +3793,7 @@
               <a:t> </a:t>
             </a:r>
             <a:r>
-              <a:rPr sz="2000">
+              <a:rPr sz="1900">
                 <a:solidFill>
                   <a:srgbClr val="F0F4FA"/>
                 </a:solidFill>
@@ -3802,7 +3802,7 @@
               <a:t>Exception</a:t>
             </a:r>
             <a:r>
-              <a:rPr sz="2000">
+              <a:rPr sz="1900">
                 <a:solidFill>
                   <a:srgbClr val="F0F4FA"/>
                 </a:solidFill>
@@ -3811,7 +3811,7 @@
               <a:t> </a:t>
             </a:r>
             <a:r>
-              <a:rPr sz="2000">
+              <a:rPr sz="1900">
                 <a:solidFill>
                   <a:srgbClr val="ABB2BF"/>
                 </a:solidFill>
@@ -3825,12 +3825,12 @@
               <a:spcAft>
                 <a:spcPts val="200"/>
               </a:spcAft>
-              <a:defRPr sz="2000">
+              <a:defRPr sz="1900">
                 <a:latin typeface="Consolas"/>
               </a:defRPr>
             </a:pPr>
             <a:r>
-              <a:rPr sz="2000">
+              <a:rPr sz="1900">
                 <a:solidFill>
                   <a:srgbClr val="C678DD"/>
                 </a:solidFill>
@@ -3839,7 +3839,7 @@
               <a:t>var</a:t>
             </a:r>
             <a:r>
-              <a:rPr sz="2000">
+              <a:rPr sz="1900">
                 <a:solidFill>
                   <a:srgbClr val="F0F4FA"/>
                 </a:solidFill>
@@ -3848,7 +3848,7 @@
               <a:t> </a:t>
             </a:r>
             <a:r>
-              <a:rPr sz="2000">
+              <a:rPr sz="1900">
                 <a:solidFill>
                   <a:srgbClr val="F0F4FA"/>
                 </a:solidFill>
@@ -3857,7 +3857,7 @@
               <a:t>thread</a:t>
             </a:r>
             <a:r>
-              <a:rPr sz="2000">
+              <a:rPr sz="1900">
                 <a:solidFill>
                   <a:srgbClr val="F0F4FA"/>
                 </a:solidFill>
@@ -3866,7 +3866,7 @@
               <a:t> </a:t>
             </a:r>
             <a:r>
-              <a:rPr sz="2000">
+              <a:rPr sz="1900">
                 <a:solidFill>
                   <a:srgbClr val="56B6C2"/>
                 </a:solidFill>
@@ -3875,7 +3875,7 @@
               <a:t>=</a:t>
             </a:r>
             <a:r>
-              <a:rPr sz="2000">
+              <a:rPr sz="1900">
                 <a:solidFill>
                   <a:srgbClr val="F0F4FA"/>
                 </a:solidFill>
@@ -3884,7 +3884,7 @@
               <a:t> </a:t>
             </a:r>
             <a:r>
-              <a:rPr sz="2000">
+              <a:rPr sz="1900">
                 <a:solidFill>
                   <a:srgbClr val="F0F4FA"/>
                 </a:solidFill>
@@ -3893,7 +3893,7 @@
               <a:t>Thread</a:t>
             </a:r>
             <a:r>
-              <a:rPr sz="2000">
+              <a:rPr sz="1900">
                 <a:solidFill>
                   <a:srgbClr val="ABB2BF"/>
                 </a:solidFill>
@@ -3902,7 +3902,7 @@
               <a:t>.</a:t>
             </a:r>
             <a:r>
-              <a:rPr sz="2000">
+              <a:rPr sz="1900">
                 <a:solidFill>
                   <a:srgbClr val="F0F4FA"/>
                 </a:solidFill>
@@ -3911,7 +3911,7 @@
               <a:t>startVirtualThread</a:t>
             </a:r>
             <a:r>
-              <a:rPr sz="2000">
+              <a:rPr sz="1900">
                 <a:solidFill>
                   <a:srgbClr val="ABB2BF"/>
                 </a:solidFill>
@@ -3920,7 +3920,7 @@
               <a:t>(</a:t>
             </a:r>
             <a:r>
-              <a:rPr sz="2000">
+              <a:rPr sz="1900">
                 <a:solidFill>
                   <a:srgbClr val="ABB2BF"/>
                 </a:solidFill>
@@ -3929,7 +3929,7 @@
               <a:t>(</a:t>
             </a:r>
             <a:r>
-              <a:rPr sz="2000">
+              <a:rPr sz="1900">
                 <a:solidFill>
                   <a:srgbClr val="ABB2BF"/>
                 </a:solidFill>
@@ -3938,7 +3938,7 @@
               <a:t>)</a:t>
             </a:r>
             <a:r>
-              <a:rPr sz="2000">
+              <a:rPr sz="1900">
                 <a:solidFill>
                   <a:srgbClr val="F0F4FA"/>
                 </a:solidFill>
@@ -3947,7 +3947,7 @@
               <a:t> </a:t>
             </a:r>
             <a:r>
-              <a:rPr sz="2000">
+              <a:rPr sz="1900">
                 <a:solidFill>
                   <a:srgbClr val="56B6C2"/>
                 </a:solidFill>
@@ -3956,7 +3956,7 @@
               <a:t>-</a:t>
             </a:r>
             <a:r>
-              <a:rPr sz="2000">
+              <a:rPr sz="1900">
                 <a:solidFill>
                   <a:srgbClr val="56B6C2"/>
                 </a:solidFill>
@@ -3965,7 +3965,7 @@
               <a:t>&gt;</a:t>
             </a:r>
             <a:r>
-              <a:rPr sz="2000">
+              <a:rPr sz="1900">
                 <a:solidFill>
                   <a:srgbClr val="F0F4FA"/>
                 </a:solidFill>
@@ -3974,7 +3974,7 @@
               <a:t> </a:t>
             </a:r>
             <a:r>
-              <a:rPr sz="2000">
+              <a:rPr sz="1900">
                 <a:solidFill>
                   <a:srgbClr val="ABB2BF"/>
                 </a:solidFill>
@@ -3988,12 +3988,12 @@
               <a:spcAft>
                 <a:spcPts val="200"/>
               </a:spcAft>
-              <a:defRPr sz="2000">
+              <a:defRPr sz="1900">
                 <a:latin typeface="Consolas"/>
               </a:defRPr>
             </a:pPr>
             <a:r>
-              <a:rPr sz="2000">
+              <a:rPr sz="1900">
                 <a:solidFill>
                   <a:srgbClr val="F0F4FA"/>
                 </a:solidFill>
@@ -4002,7 +4002,7 @@
               <a:t>System</a:t>
             </a:r>
             <a:r>
-              <a:rPr sz="2000">
+              <a:rPr sz="1900">
                 <a:solidFill>
                   <a:srgbClr val="ABB2BF"/>
                 </a:solidFill>
@@ -4011,7 +4011,7 @@
               <a:t>.</a:t>
             </a:r>
             <a:r>
-              <a:rPr sz="2000">
+              <a:rPr sz="1900">
                 <a:solidFill>
                   <a:srgbClr val="F0F4FA"/>
                 </a:solidFill>
@@ -4020,7 +4020,7 @@
               <a:t>out</a:t>
             </a:r>
             <a:r>
-              <a:rPr sz="2000">
+              <a:rPr sz="1900">
                 <a:solidFill>
                   <a:srgbClr val="ABB2BF"/>
                 </a:solidFill>
@@ -4029,7 +4029,7 @@
               <a:t>.</a:t>
             </a:r>
             <a:r>
-              <a:rPr sz="2000">
+              <a:rPr sz="1900">
                 <a:solidFill>
                   <a:srgbClr val="F0F4FA"/>
                 </a:solidFill>
@@ -4038,7 +4038,7 @@
               <a:t>println</a:t>
             </a:r>
             <a:r>
-              <a:rPr sz="2000">
+              <a:rPr sz="1900">
                 <a:solidFill>
                   <a:srgbClr val="ABB2BF"/>
                 </a:solidFill>
@@ -4047,7 +4047,7 @@
               <a:t>(</a:t>
             </a:r>
             <a:r>
-              <a:rPr sz="2000">
+              <a:rPr sz="1900">
                 <a:solidFill>
                   <a:srgbClr val="98C379"/>
                 </a:solidFill>
@@ -4056,7 +4056,7 @@
               <a:t>"</a:t>
             </a:r>
             <a:r>
-              <a:rPr sz="2000">
+              <a:rPr sz="1900">
                 <a:solidFill>
                   <a:srgbClr val="98C379"/>
                 </a:solidFill>
@@ -4065,7 +4065,7 @@
               <a:t>Virtual Thread Executing!</a:t>
             </a:r>
             <a:r>
-              <a:rPr sz="2000">
+              <a:rPr sz="1900">
                 <a:solidFill>
                   <a:srgbClr val="98C379"/>
                 </a:solidFill>
@@ -4074,7 +4074,7 @@
               <a:t>"</a:t>
             </a:r>
             <a:r>
-              <a:rPr sz="2000">
+              <a:rPr sz="1900">
                 <a:solidFill>
                   <a:srgbClr val="ABB2BF"/>
                 </a:solidFill>
@@ -4083,7 +4083,7 @@
               <a:t>)</a:t>
             </a:r>
             <a:r>
-              <a:rPr sz="2000">
+              <a:rPr sz="1900">
                 <a:solidFill>
                   <a:srgbClr val="ABB2BF"/>
                 </a:solidFill>
@@ -4097,12 +4097,12 @@
               <a:spcAft>
                 <a:spcPts val="200"/>
               </a:spcAft>
-              <a:defRPr sz="2000">
+              <a:defRPr sz="1900">
                 <a:latin typeface="Consolas"/>
               </a:defRPr>
             </a:pPr>
             <a:r>
-              <a:rPr sz="2000">
+              <a:rPr sz="1900">
                 <a:solidFill>
                   <a:srgbClr val="ABB2BF"/>
                 </a:solidFill>
@@ -4111,7 +4111,7 @@
               <a:t>}</a:t>
             </a:r>
             <a:r>
-              <a:rPr sz="2000">
+              <a:rPr sz="1900">
                 <a:solidFill>
                   <a:srgbClr val="ABB2BF"/>
                 </a:solidFill>
@@ -4120,7 +4120,7 @@
               <a:t>)</a:t>
             </a:r>
             <a:r>
-              <a:rPr sz="2000">
+              <a:rPr sz="1900">
                 <a:solidFill>
                   <a:srgbClr val="ABB2BF"/>
                 </a:solidFill>
@@ -4134,12 +4134,12 @@
               <a:spcAft>
                 <a:spcPts val="200"/>
               </a:spcAft>
-              <a:defRPr sz="2000">
+              <a:defRPr sz="1900">
                 <a:latin typeface="Consolas"/>
               </a:defRPr>
             </a:pPr>
             <a:r>
-              <a:rPr sz="2000">
+              <a:rPr sz="1900">
                 <a:solidFill>
                   <a:srgbClr val="F0F4FA"/>
                 </a:solidFill>
@@ -4148,7 +4148,7 @@
               <a:t>thread</a:t>
             </a:r>
             <a:r>
-              <a:rPr sz="2000">
+              <a:rPr sz="1900">
                 <a:solidFill>
                   <a:srgbClr val="ABB2BF"/>
                 </a:solidFill>
@@ -4157,7 +4157,7 @@
               <a:t>.</a:t>
             </a:r>
             <a:r>
-              <a:rPr sz="2000">
+              <a:rPr sz="1900">
                 <a:solidFill>
                   <a:srgbClr val="F0F4FA"/>
                 </a:solidFill>
@@ -4166,7 +4166,7 @@
               <a:t>join</a:t>
             </a:r>
             <a:r>
-              <a:rPr sz="2000">
+              <a:rPr sz="1900">
                 <a:solidFill>
                   <a:srgbClr val="ABB2BF"/>
                 </a:solidFill>
@@ -4175,7 +4175,7 @@
               <a:t>(</a:t>
             </a:r>
             <a:r>
-              <a:rPr sz="2000">
+              <a:rPr sz="1900">
                 <a:solidFill>
                   <a:srgbClr val="ABB2BF"/>
                 </a:solidFill>
@@ -4184,7 +4184,7 @@
               <a:t>)</a:t>
             </a:r>
             <a:r>
-              <a:rPr sz="2000">
+              <a:rPr sz="1900">
                 <a:solidFill>
                   <a:srgbClr val="ABB2BF"/>
                 </a:solidFill>
@@ -4198,12 +4198,12 @@
               <a:spcAft>
                 <a:spcPts val="200"/>
               </a:spcAft>
-              <a:defRPr sz="2000">
+              <a:defRPr sz="1900">
                 <a:latin typeface="Consolas"/>
               </a:defRPr>
             </a:pPr>
             <a:r>
-              <a:rPr sz="2000">
+              <a:rPr sz="1900">
                 <a:solidFill>
                   <a:srgbClr val="ABB2BF"/>
                 </a:solidFill>
@@ -4217,12 +4217,12 @@
               <a:spcAft>
                 <a:spcPts val="200"/>
               </a:spcAft>
-              <a:defRPr sz="2000">
+              <a:defRPr sz="1900">
                 <a:latin typeface="Consolas"/>
               </a:defRPr>
             </a:pPr>
             <a:r>
-              <a:rPr sz="2000">
+              <a:rPr sz="1900">
                 <a:solidFill>
                   <a:srgbClr val="ABB2BF"/>
                 </a:solidFill>
@@ -4238,7 +4238,7 @@
               </a:spcBef>
             </a:pPr>
             <a:r>
-              <a:rPr sz="1800" b="1">
+              <a:rPr sz="1700" b="1">
                 <a:solidFill>
                   <a:srgbClr val="4ADE80"/>
                 </a:solidFill>
@@ -4247,7 +4247,7 @@
               <a:t>Expected Output: </a:t>
             </a:r>
             <a:r>
-              <a:rPr sz="1800">
+              <a:rPr sz="1700">
                 <a:solidFill>
                   <a:srgbClr val="E2E8F0"/>
                 </a:solidFill>
@@ -4309,8 +4309,8 @@
         </p:nvSpPr>
         <p:spPr>
           <a:xfrm>
-            <a:off x="1981199" y="1174750"/>
-            <a:ext cx="8229599" cy="425449"/>
+            <a:off x="1981199" y="1168400"/>
+            <a:ext cx="8229599" cy="438149"/>
           </a:xfrm>
           <a:prstGeom prst="rect">
             <a:avLst/>
@@ -4326,7 +4326,7 @@
             <a:pPr algn="l">
               <a:defRPr sz="4400" b="1">
                 <a:solidFill>
-                  <a:srgbClr val="425C80"/>
+                  <a:srgbClr val="1E2653"/>
                 </a:solidFill>
                 <a:latin typeface="Arial"/>
               </a:defRPr>
@@ -4360,7 +4360,7 @@
           <a:lstStyle/>
           <a:p>
             <a:pPr algn="l">
-              <a:defRPr sz="1300">
+              <a:defRPr sz="1200">
                 <a:solidFill>
                   <a:srgbClr val="64748B"/>
                 </a:solidFill>
@@ -4381,18 +4381,18 @@
         </p:nvSpPr>
         <p:spPr>
           <a:xfrm>
-            <a:off x="1981199" y="1778000"/>
-            <a:ext cx="3994149" cy="838200"/>
+            <a:off x="1981199" y="1784350"/>
+            <a:ext cx="3505199" cy="2159000"/>
           </a:xfrm>
           <a:prstGeom prst="roundRect">
             <a:avLst/>
           </a:prstGeom>
           <a:solidFill>
-            <a:srgbClr val="FFFFFF"/>
+            <a:srgbClr val="F8FAFC"/>
           </a:solidFill>
           <a:ln w="12700">
             <a:solidFill>
-              <a:srgbClr val="6E9AD6"/>
+              <a:srgbClr val="E2E8F0"/>
             </a:solidFill>
           </a:ln>
         </p:spPr>
@@ -4420,7 +4420,7 @@
               </a:spcAft>
               <a:defRPr sz="3000">
                 <a:solidFill>
-                  <a:srgbClr val="0F172A"/>
+                  <a:srgbClr val="1E293B"/>
                 </a:solidFill>
                 <a:latin typeface="Segoe UI"/>
               </a:defRPr>
@@ -4436,7 +4436,7 @@
               </a:spcAft>
               <a:defRPr sz="3000">
                 <a:solidFill>
-                  <a:srgbClr val="0F172A"/>
+                  <a:srgbClr val="1E293B"/>
                 </a:solidFill>
                 <a:latin typeface="Segoe UI"/>
               </a:defRPr>
@@ -4452,7 +4452,7 @@
               </a:spcAft>
               <a:defRPr sz="3000">
                 <a:solidFill>
-                  <a:srgbClr val="0F172A"/>
+                  <a:srgbClr val="1E293B"/>
                 </a:solidFill>
                 <a:latin typeface="Segoe UI"/>
               </a:defRPr>
@@ -4471,18 +4471,18 @@
         </p:nvSpPr>
         <p:spPr>
           <a:xfrm>
-            <a:off x="6216649" y="1778000"/>
-            <a:ext cx="3994149" cy="1600200"/>
+            <a:off x="5740399" y="1784350"/>
+            <a:ext cx="4470399" cy="2159000"/>
           </a:xfrm>
           <a:prstGeom prst="roundRect">
             <a:avLst/>
           </a:prstGeom>
           <a:solidFill>
-            <a:srgbClr val="1E1E2E"/>
+            <a:srgbClr val="0F172A"/>
           </a:solidFill>
-          <a:ln w="19050">
+          <a:ln w="12700">
             <a:solidFill>
-              <a:srgbClr val="6E9AD6"/>
+              <a:srgbClr val="1E293B"/>
             </a:solidFill>
           </a:ln>
         </p:spPr>
@@ -4508,9 +4508,9 @@
               <a:spcAft>
                 <a:spcPts val="800"/>
               </a:spcAft>
-              <a:defRPr sz="1300">
-                <a:solidFill>
-                  <a:srgbClr val="8C9BAF"/>
+              <a:defRPr sz="1200">
+                <a:solidFill>
+                  <a:srgbClr val="60A5FA"/>
                 </a:solidFill>
                 <a:latin typeface="Consolas"/>
               </a:defRPr>
@@ -4524,12 +4524,12 @@
               <a:spcAft>
                 <a:spcPts val="200"/>
               </a:spcAft>
-              <a:defRPr sz="2000">
+              <a:defRPr sz="1700">
                 <a:latin typeface="Consolas"/>
               </a:defRPr>
             </a:pPr>
             <a:r>
-              <a:rPr sz="2000">
+              <a:rPr sz="1700">
                 <a:solidFill>
                   <a:srgbClr val="C678DD"/>
                 </a:solidFill>
@@ -4538,7 +4538,7 @@
               <a:t>public</a:t>
             </a:r>
             <a:r>
-              <a:rPr sz="2000">
+              <a:rPr sz="1700">
                 <a:solidFill>
                   <a:srgbClr val="F0F4FA"/>
                 </a:solidFill>
@@ -4547,7 +4547,7 @@
               <a:t> </a:t>
             </a:r>
             <a:r>
-              <a:rPr sz="2000">
+              <a:rPr sz="1700">
                 <a:solidFill>
                   <a:srgbClr val="C678DD"/>
                 </a:solidFill>
@@ -4556,7 +4556,7 @@
               <a:t>class</a:t>
             </a:r>
             <a:r>
-              <a:rPr sz="2000">
+              <a:rPr sz="1700">
                 <a:solidFill>
                   <a:srgbClr val="F0F4FA"/>
                 </a:solidFill>
@@ -4565,7 +4565,7 @@
               <a:t> </a:t>
             </a:r>
             <a:r>
-              <a:rPr sz="2000">
+              <a:rPr sz="1700">
                 <a:solidFill>
                   <a:srgbClr val="E5C07B"/>
                 </a:solidFill>
@@ -4574,7 +4574,7 @@
               <a:t>Solution</a:t>
             </a:r>
             <a:r>
-              <a:rPr sz="2000">
+              <a:rPr sz="1700">
                 <a:solidFill>
                   <a:srgbClr val="F0F4FA"/>
                 </a:solidFill>
@@ -4583,7 +4583,7 @@
               <a:t> </a:t>
             </a:r>
             <a:r>
-              <a:rPr sz="2000">
+              <a:rPr sz="1700">
                 <a:solidFill>
                   <a:srgbClr val="ABB2BF"/>
                 </a:solidFill>
@@ -4597,12 +4597,12 @@
               <a:spcAft>
                 <a:spcPts val="200"/>
               </a:spcAft>
-              <a:defRPr sz="2000">
+              <a:defRPr sz="1700">
                 <a:latin typeface="Consolas"/>
               </a:defRPr>
             </a:pPr>
             <a:r>
-              <a:rPr sz="2000">
+              <a:rPr sz="1700">
                 <a:solidFill>
                   <a:srgbClr val="C678DD"/>
                 </a:solidFill>
@@ -4611,7 +4611,7 @@
               <a:t>public</a:t>
             </a:r>
             <a:r>
-              <a:rPr sz="2000">
+              <a:rPr sz="1700">
                 <a:solidFill>
                   <a:srgbClr val="F0F4FA"/>
                 </a:solidFill>
@@ -4620,7 +4620,7 @@
               <a:t> </a:t>
             </a:r>
             <a:r>
-              <a:rPr sz="2000">
+              <a:rPr sz="1700">
                 <a:solidFill>
                   <a:srgbClr val="C678DD"/>
                 </a:solidFill>
@@ -4629,7 +4629,7 @@
               <a:t>static</a:t>
             </a:r>
             <a:r>
-              <a:rPr sz="2000">
+              <a:rPr sz="1700">
                 <a:solidFill>
                   <a:srgbClr val="F0F4FA"/>
                 </a:solidFill>
@@ -4638,7 +4638,7 @@
               <a:t> </a:t>
             </a:r>
             <a:r>
-              <a:rPr sz="2000">
+              <a:rPr sz="1700">
                 <a:solidFill>
                   <a:srgbClr val="C678DD"/>
                 </a:solidFill>
@@ -4647,7 +4647,7 @@
               <a:t>void</a:t>
             </a:r>
             <a:r>
-              <a:rPr sz="2000">
+              <a:rPr sz="1700">
                 <a:solidFill>
                   <a:srgbClr val="F0F4FA"/>
                 </a:solidFill>
@@ -4656,7 +4656,7 @@
               <a:t> </a:t>
             </a:r>
             <a:r>
-              <a:rPr sz="2000">
+              <a:rPr sz="1700">
                 <a:solidFill>
                   <a:srgbClr val="61AFEF"/>
                 </a:solidFill>
@@ -4665,7 +4665,7 @@
               <a:t>main</a:t>
             </a:r>
             <a:r>
-              <a:rPr sz="2000">
+              <a:rPr sz="1700">
                 <a:solidFill>
                   <a:srgbClr val="ABB2BF"/>
                 </a:solidFill>
@@ -4674,7 +4674,7 @@
               <a:t>(</a:t>
             </a:r>
             <a:r>
-              <a:rPr sz="2000">
+              <a:rPr sz="1700">
                 <a:solidFill>
                   <a:srgbClr val="F0F4FA"/>
                 </a:solidFill>
@@ -4683,7 +4683,7 @@
               <a:t>String</a:t>
             </a:r>
             <a:r>
-              <a:rPr sz="2000">
+              <a:rPr sz="1700">
                 <a:solidFill>
                   <a:srgbClr val="56B6C2"/>
                 </a:solidFill>
@@ -4692,7 +4692,7 @@
               <a:t>[</a:t>
             </a:r>
             <a:r>
-              <a:rPr sz="2000">
+              <a:rPr sz="1700">
                 <a:solidFill>
                   <a:srgbClr val="56B6C2"/>
                 </a:solidFill>
@@ -4701,7 +4701,7 @@
               <a:t>]</a:t>
             </a:r>
             <a:r>
-              <a:rPr sz="2000">
+              <a:rPr sz="1700">
                 <a:solidFill>
                   <a:srgbClr val="F0F4FA"/>
                 </a:solidFill>
@@ -4710,7 +4710,7 @@
               <a:t> </a:t>
             </a:r>
             <a:r>
-              <a:rPr sz="2000">
+              <a:rPr sz="1700">
                 <a:solidFill>
                   <a:srgbClr val="F0F4FA"/>
                 </a:solidFill>
@@ -4719,7 +4719,7 @@
               <a:t>args</a:t>
             </a:r>
             <a:r>
-              <a:rPr sz="2000">
+              <a:rPr sz="1700">
                 <a:solidFill>
                   <a:srgbClr val="ABB2BF"/>
                 </a:solidFill>
@@ -4728,7 +4728,7 @@
               <a:t>)</a:t>
             </a:r>
             <a:r>
-              <a:rPr sz="2000">
+              <a:rPr sz="1700">
                 <a:solidFill>
                   <a:srgbClr val="F0F4FA"/>
                 </a:solidFill>
@@ -4737,7 +4737,7 @@
               <a:t> </a:t>
             </a:r>
             <a:r>
-              <a:rPr sz="2000">
+              <a:rPr sz="1700">
                 <a:solidFill>
                   <a:srgbClr val="ABB2BF"/>
                 </a:solidFill>
@@ -4751,12 +4751,12 @@
               <a:spcAft>
                 <a:spcPts val="200"/>
               </a:spcAft>
-              <a:defRPr sz="2000">
+              <a:defRPr sz="1700">
                 <a:latin typeface="Consolas"/>
               </a:defRPr>
             </a:pPr>
             <a:r>
-              <a:rPr sz="2000">
+              <a:rPr sz="1700">
                 <a:solidFill>
                   <a:srgbClr val="F0F4FA"/>
                 </a:solidFill>
@@ -4765,7 +4765,7 @@
               <a:t>String</a:t>
             </a:r>
             <a:r>
-              <a:rPr sz="2000">
+              <a:rPr sz="1700">
                 <a:solidFill>
                   <a:srgbClr val="F0F4FA"/>
                 </a:solidFill>
@@ -4774,7 +4774,7 @@
               <a:t> </a:t>
             </a:r>
             <a:r>
-              <a:rPr sz="2000">
+              <a:rPr sz="1700">
                 <a:solidFill>
                   <a:srgbClr val="F0F4FA"/>
                 </a:solidFill>
@@ -4783,7 +4783,7 @@
               <a:t>status</a:t>
             </a:r>
             <a:r>
-              <a:rPr sz="2000">
+              <a:rPr sz="1700">
                 <a:solidFill>
                   <a:srgbClr val="F0F4FA"/>
                 </a:solidFill>
@@ -4792,7 +4792,7 @@
               <a:t> </a:t>
             </a:r>
             <a:r>
-              <a:rPr sz="2000">
+              <a:rPr sz="1700">
                 <a:solidFill>
                   <a:srgbClr val="56B6C2"/>
                 </a:solidFill>
@@ -4801,7 +4801,7 @@
               <a:t>=</a:t>
             </a:r>
             <a:r>
-              <a:rPr sz="2000">
+              <a:rPr sz="1700">
                 <a:solidFill>
                   <a:srgbClr val="F0F4FA"/>
                 </a:solidFill>
@@ -4810,7 +4810,7 @@
               <a:t> </a:t>
             </a:r>
             <a:r>
-              <a:rPr sz="2000">
+              <a:rPr sz="1700">
                 <a:solidFill>
                   <a:srgbClr val="98C379"/>
                 </a:solidFill>
@@ -4819,7 +4819,7 @@
               <a:t>"</a:t>
             </a:r>
             <a:r>
-              <a:rPr sz="2000">
+              <a:rPr sz="1700">
                 <a:solidFill>
                   <a:srgbClr val="98C379"/>
                 </a:solidFill>
@@ -4828,7 +4828,7 @@
               <a:t>UP</a:t>
             </a:r>
             <a:r>
-              <a:rPr sz="2000">
+              <a:rPr sz="1700">
                 <a:solidFill>
                   <a:srgbClr val="98C379"/>
                 </a:solidFill>
@@ -4837,7 +4837,7 @@
               <a:t>"</a:t>
             </a:r>
             <a:r>
-              <a:rPr sz="2000">
+              <a:rPr sz="1700">
                 <a:solidFill>
                   <a:srgbClr val="ABB2BF"/>
                 </a:solidFill>
@@ -4851,12 +4851,12 @@
               <a:spcAft>
                 <a:spcPts val="200"/>
               </a:spcAft>
-              <a:defRPr sz="2000">
+              <a:defRPr sz="1700">
                 <a:latin typeface="Consolas"/>
               </a:defRPr>
             </a:pPr>
             <a:r>
-              <a:rPr sz="2000">
+              <a:rPr sz="1700">
                 <a:solidFill>
                   <a:srgbClr val="C678DD"/>
                 </a:solidFill>
@@ -4865,7 +4865,7 @@
               <a:t>int</a:t>
             </a:r>
             <a:r>
-              <a:rPr sz="2000">
+              <a:rPr sz="1700">
                 <a:solidFill>
                   <a:srgbClr val="F0F4FA"/>
                 </a:solidFill>
@@ -4874,7 +4874,7 @@
               <a:t> </a:t>
             </a:r>
             <a:r>
-              <a:rPr sz="2000">
+              <a:rPr sz="1700">
                 <a:solidFill>
                   <a:srgbClr val="F0F4FA"/>
                 </a:solidFill>
@@ -4883,7 +4883,7 @@
               <a:t>port</a:t>
             </a:r>
             <a:r>
-              <a:rPr sz="2000">
+              <a:rPr sz="1700">
                 <a:solidFill>
                   <a:srgbClr val="F0F4FA"/>
                 </a:solidFill>
@@ -4892,7 +4892,7 @@
               <a:t> </a:t>
             </a:r>
             <a:r>
-              <a:rPr sz="2000">
+              <a:rPr sz="1700">
                 <a:solidFill>
                   <a:srgbClr val="56B6C2"/>
                 </a:solidFill>
@@ -4901,7 +4901,7 @@
               <a:t>=</a:t>
             </a:r>
             <a:r>
-              <a:rPr sz="2000">
+              <a:rPr sz="1700">
                 <a:solidFill>
                   <a:srgbClr val="F0F4FA"/>
                 </a:solidFill>
@@ -4910,7 +4910,7 @@
               <a:t> </a:t>
             </a:r>
             <a:r>
-              <a:rPr sz="2000">
+              <a:rPr sz="1700">
                 <a:solidFill>
                   <a:srgbClr val="D19A66"/>
                 </a:solidFill>
@@ -4919,7 +4919,7 @@
               <a:t>8080</a:t>
             </a:r>
             <a:r>
-              <a:rPr sz="2000">
+              <a:rPr sz="1700">
                 <a:solidFill>
                   <a:srgbClr val="ABB2BF"/>
                 </a:solidFill>
@@ -4933,12 +4933,12 @@
               <a:spcAft>
                 <a:spcPts val="200"/>
               </a:spcAft>
-              <a:defRPr sz="2000">
+              <a:defRPr sz="1700">
                 <a:latin typeface="Consolas"/>
               </a:defRPr>
             </a:pPr>
             <a:r>
-              <a:rPr sz="2000">
+              <a:rPr sz="1700">
                 <a:solidFill>
                   <a:srgbClr val="F0F4FA"/>
                 </a:solidFill>
@@ -4947,7 +4947,7 @@
               <a:t>System</a:t>
             </a:r>
             <a:r>
-              <a:rPr sz="2000">
+              <a:rPr sz="1700">
                 <a:solidFill>
                   <a:srgbClr val="ABB2BF"/>
                 </a:solidFill>
@@ -4956,7 +4956,7 @@
               <a:t>.</a:t>
             </a:r>
             <a:r>
-              <a:rPr sz="2000">
+              <a:rPr sz="1700">
                 <a:solidFill>
                   <a:srgbClr val="F0F4FA"/>
                 </a:solidFill>
@@ -4965,7 +4965,7 @@
               <a:t>out</a:t>
             </a:r>
             <a:r>
-              <a:rPr sz="2000">
+              <a:rPr sz="1700">
                 <a:solidFill>
                   <a:srgbClr val="ABB2BF"/>
                 </a:solidFill>
@@ -4974,7 +4974,7 @@
               <a:t>.</a:t>
             </a:r>
             <a:r>
-              <a:rPr sz="2000">
+              <a:rPr sz="1700">
                 <a:solidFill>
                   <a:srgbClr val="F0F4FA"/>
                 </a:solidFill>
@@ -4983,7 +4983,7 @@
               <a:t>println</a:t>
             </a:r>
             <a:r>
-              <a:rPr sz="2000">
+              <a:rPr sz="1700">
                 <a:solidFill>
                   <a:srgbClr val="ABB2BF"/>
                 </a:solidFill>
@@ -4992,7 +4992,7 @@
               <a:t>(</a:t>
             </a:r>
             <a:r>
-              <a:rPr sz="2000">
+              <a:rPr sz="1700">
                 <a:solidFill>
                   <a:srgbClr val="98C379"/>
                 </a:solidFill>
@@ -5001,7 +5001,7 @@
               <a:t>"</a:t>
             </a:r>
             <a:r>
-              <a:rPr sz="2000">
+              <a:rPr sz="1700">
                 <a:solidFill>
                   <a:srgbClr val="98C379"/>
                 </a:solidFill>
@@ -5010,7 +5010,7 @@
               <a:t>Service: </a:t>
             </a:r>
             <a:r>
-              <a:rPr sz="2000">
+              <a:rPr sz="1700">
                 <a:solidFill>
                   <a:srgbClr val="98C379"/>
                 </a:solidFill>
@@ -5019,7 +5019,7 @@
               <a:t>"</a:t>
             </a:r>
             <a:r>
-              <a:rPr sz="2000">
+              <a:rPr sz="1700">
                 <a:solidFill>
                   <a:srgbClr val="F0F4FA"/>
                 </a:solidFill>
@@ -5028,7 +5028,7 @@
               <a:t> </a:t>
             </a:r>
             <a:r>
-              <a:rPr sz="2000">
+              <a:rPr sz="1700">
                 <a:solidFill>
                   <a:srgbClr val="56B6C2"/>
                 </a:solidFill>
@@ -5037,7 +5037,7 @@
               <a:t>+</a:t>
             </a:r>
             <a:r>
-              <a:rPr sz="2000">
+              <a:rPr sz="1700">
                 <a:solidFill>
                   <a:srgbClr val="F0F4FA"/>
                 </a:solidFill>
@@ -5046,7 +5046,7 @@
               <a:t> </a:t>
             </a:r>
             <a:r>
-              <a:rPr sz="2000">
+              <a:rPr sz="1700">
                 <a:solidFill>
                   <a:srgbClr val="F0F4FA"/>
                 </a:solidFill>
@@ -5055,7 +5055,7 @@
               <a:t>status</a:t>
             </a:r>
             <a:r>
-              <a:rPr sz="2000">
+              <a:rPr sz="1700">
                 <a:solidFill>
                   <a:srgbClr val="F0F4FA"/>
                 </a:solidFill>
@@ -5064,7 +5064,7 @@
               <a:t> </a:t>
             </a:r>
             <a:r>
-              <a:rPr sz="2000">
+              <a:rPr sz="1700">
                 <a:solidFill>
                   <a:srgbClr val="56B6C2"/>
                 </a:solidFill>
@@ -5073,7 +5073,7 @@
               <a:t>+</a:t>
             </a:r>
             <a:r>
-              <a:rPr sz="2000">
+              <a:rPr sz="1700">
                 <a:solidFill>
                   <a:srgbClr val="F0F4FA"/>
                 </a:solidFill>
@@ -5082,7 +5082,7 @@
               <a:t> </a:t>
             </a:r>
             <a:r>
-              <a:rPr sz="2000">
+              <a:rPr sz="1700">
                 <a:solidFill>
                   <a:srgbClr val="98C379"/>
                 </a:solidFill>
@@ -5091,7 +5091,7 @@
               <a:t>"</a:t>
             </a:r>
             <a:r>
-              <a:rPr sz="2000">
+              <a:rPr sz="1700">
                 <a:solidFill>
                   <a:srgbClr val="98C379"/>
                 </a:solidFill>
@@ -5100,7 +5100,7 @@
               <a:t> on: </a:t>
             </a:r>
             <a:r>
-              <a:rPr sz="2000">
+              <a:rPr sz="1700">
                 <a:solidFill>
                   <a:srgbClr val="98C379"/>
                 </a:solidFill>
@@ -5109,7 +5109,7 @@
               <a:t>"</a:t>
             </a:r>
             <a:r>
-              <a:rPr sz="2000">
+              <a:rPr sz="1700">
                 <a:solidFill>
                   <a:srgbClr val="F0F4FA"/>
                 </a:solidFill>
@@ -5118,7 +5118,7 @@
               <a:t> </a:t>
             </a:r>
             <a:r>
-              <a:rPr sz="2000">
+              <a:rPr sz="1700">
                 <a:solidFill>
                   <a:srgbClr val="56B6C2"/>
                 </a:solidFill>
@@ -5127,7 +5127,7 @@
               <a:t>+</a:t>
             </a:r>
             <a:r>
-              <a:rPr sz="2000">
+              <a:rPr sz="1700">
                 <a:solidFill>
                   <a:srgbClr val="F0F4FA"/>
                 </a:solidFill>
@@ -5136,7 +5136,7 @@
               <a:t> </a:t>
             </a:r>
             <a:r>
-              <a:rPr sz="2000">
+              <a:rPr sz="1700">
                 <a:solidFill>
                   <a:srgbClr val="F0F4FA"/>
                 </a:solidFill>
@@ -5145,7 +5145,7 @@
               <a:t>port</a:t>
             </a:r>
             <a:r>
-              <a:rPr sz="2000">
+              <a:rPr sz="1700">
                 <a:solidFill>
                   <a:srgbClr val="ABB2BF"/>
                 </a:solidFill>
@@ -5154,7 +5154,7 @@
               <a:t>)</a:t>
             </a:r>
             <a:r>
-              <a:rPr sz="2000">
+              <a:rPr sz="1700">
                 <a:solidFill>
                   <a:srgbClr val="ABB2BF"/>
                 </a:solidFill>
@@ -5168,12 +5168,12 @@
               <a:spcAft>
                 <a:spcPts val="200"/>
               </a:spcAft>
-              <a:defRPr sz="2000">
+              <a:defRPr sz="1700">
                 <a:latin typeface="Consolas"/>
               </a:defRPr>
             </a:pPr>
             <a:r>
-              <a:rPr sz="2000">
+              <a:rPr sz="1700">
                 <a:solidFill>
                   <a:srgbClr val="ABB2BF"/>
                 </a:solidFill>
@@ -5187,12 +5187,12 @@
               <a:spcAft>
                 <a:spcPts val="200"/>
               </a:spcAft>
-              <a:defRPr sz="2000">
+              <a:defRPr sz="1700">
                 <a:latin typeface="Consolas"/>
               </a:defRPr>
             </a:pPr>
             <a:r>
-              <a:rPr sz="2000">
+              <a:rPr sz="1700">
                 <a:solidFill>
                   <a:srgbClr val="ABB2BF"/>
                 </a:solidFill>
@@ -5208,7 +5208,7 @@
               </a:spcBef>
             </a:pPr>
             <a:r>
-              <a:rPr sz="1800" b="1">
+              <a:rPr sz="1500" b="1">
                 <a:solidFill>
                   <a:srgbClr val="4ADE80"/>
                 </a:solidFill>
@@ -5217,7 +5217,7 @@
               <a:t>Expected Output: </a:t>
             </a:r>
             <a:r>
-              <a:rPr sz="1800">
+              <a:rPr sz="1500">
                 <a:solidFill>
                   <a:srgbClr val="E2E8F0"/>
                 </a:solidFill>
@@ -5279,8 +5279,8 @@
         </p:nvSpPr>
         <p:spPr>
           <a:xfrm>
-            <a:off x="1981199" y="1174750"/>
-            <a:ext cx="8229599" cy="425449"/>
+            <a:off x="1981199" y="1168400"/>
+            <a:ext cx="8229599" cy="438149"/>
           </a:xfrm>
           <a:prstGeom prst="rect">
             <a:avLst/>
@@ -5296,7 +5296,7 @@
             <a:pPr algn="l">
               <a:defRPr sz="4400" b="1">
                 <a:solidFill>
-                  <a:srgbClr val="425C80"/>
+                  <a:srgbClr val="1E2653"/>
                 </a:solidFill>
                 <a:latin typeface="Arial"/>
               </a:defRPr>
@@ -5330,7 +5330,7 @@
           <a:lstStyle/>
           <a:p>
             <a:pPr algn="l">
-              <a:defRPr sz="1300">
+              <a:defRPr sz="1200">
                 <a:solidFill>
                   <a:srgbClr val="64748B"/>
                 </a:solidFill>
@@ -5351,18 +5351,18 @@
         </p:nvSpPr>
         <p:spPr>
           <a:xfrm>
-            <a:off x="1981199" y="1778000"/>
-            <a:ext cx="3994149" cy="838200"/>
+            <a:off x="1981199" y="1784350"/>
+            <a:ext cx="3505199" cy="2159000"/>
           </a:xfrm>
           <a:prstGeom prst="roundRect">
             <a:avLst/>
           </a:prstGeom>
           <a:solidFill>
-            <a:srgbClr val="FFFFFF"/>
+            <a:srgbClr val="F8FAFC"/>
           </a:solidFill>
           <a:ln w="12700">
             <a:solidFill>
-              <a:srgbClr val="6E9AD6"/>
+              <a:srgbClr val="E2E8F0"/>
             </a:solidFill>
           </a:ln>
         </p:spPr>
@@ -5390,7 +5390,7 @@
               </a:spcAft>
               <a:defRPr sz="3000">
                 <a:solidFill>
-                  <a:srgbClr val="0F172A"/>
+                  <a:srgbClr val="1E293B"/>
                 </a:solidFill>
                 <a:latin typeface="Segoe UI"/>
               </a:defRPr>
@@ -5406,7 +5406,7 @@
               </a:spcAft>
               <a:defRPr sz="3000">
                 <a:solidFill>
-                  <a:srgbClr val="0F172A"/>
+                  <a:srgbClr val="1E293B"/>
                 </a:solidFill>
                 <a:latin typeface="Segoe UI"/>
               </a:defRPr>
@@ -5422,7 +5422,7 @@
               </a:spcAft>
               <a:defRPr sz="3000">
                 <a:solidFill>
-                  <a:srgbClr val="0F172A"/>
+                  <a:srgbClr val="1E293B"/>
                 </a:solidFill>
                 <a:latin typeface="Segoe UI"/>
               </a:defRPr>
@@ -5441,18 +5441,18 @@
         </p:nvSpPr>
         <p:spPr>
           <a:xfrm>
-            <a:off x="6216649" y="1778000"/>
-            <a:ext cx="3994149" cy="1435100"/>
+            <a:off x="5740399" y="1784350"/>
+            <a:ext cx="4470399" cy="2159000"/>
           </a:xfrm>
           <a:prstGeom prst="roundRect">
             <a:avLst/>
           </a:prstGeom>
           <a:solidFill>
-            <a:srgbClr val="1E1E2E"/>
+            <a:srgbClr val="0F172A"/>
           </a:solidFill>
-          <a:ln w="19050">
+          <a:ln w="12700">
             <a:solidFill>
-              <a:srgbClr val="6E9AD6"/>
+              <a:srgbClr val="1E293B"/>
             </a:solidFill>
           </a:ln>
         </p:spPr>
@@ -5478,9 +5478,9 @@
               <a:spcAft>
                 <a:spcPts val="800"/>
               </a:spcAft>
-              <a:defRPr sz="1300">
-                <a:solidFill>
-                  <a:srgbClr val="8C9BAF"/>
+              <a:defRPr sz="1200">
+                <a:solidFill>
+                  <a:srgbClr val="60A5FA"/>
                 </a:solidFill>
                 <a:latin typeface="Consolas"/>
               </a:defRPr>
@@ -6059,8 +6059,8 @@
         </p:nvSpPr>
         <p:spPr>
           <a:xfrm>
-            <a:off x="1981199" y="1174750"/>
-            <a:ext cx="8229599" cy="425449"/>
+            <a:off x="1981199" y="1168400"/>
+            <a:ext cx="8229599" cy="438149"/>
           </a:xfrm>
           <a:prstGeom prst="rect">
             <a:avLst/>
@@ -6076,7 +6076,7 @@
             <a:pPr algn="l">
               <a:defRPr sz="4400" b="1">
                 <a:solidFill>
-                  <a:srgbClr val="425C80"/>
+                  <a:srgbClr val="1E2653"/>
                 </a:solidFill>
                 <a:latin typeface="Arial"/>
               </a:defRPr>
@@ -6110,7 +6110,7 @@
           <a:lstStyle/>
           <a:p>
             <a:pPr algn="l">
-              <a:defRPr sz="1300">
+              <a:defRPr sz="1200">
                 <a:solidFill>
                   <a:srgbClr val="64748B"/>
                 </a:solidFill>
@@ -6131,18 +6131,18 @@
         </p:nvSpPr>
         <p:spPr>
           <a:xfrm>
-            <a:off x="2171699" y="1841500"/>
-            <a:ext cx="7848599" cy="869950"/>
+            <a:off x="2171699" y="1847849"/>
+            <a:ext cx="7848599" cy="889000"/>
           </a:xfrm>
           <a:prstGeom prst="roundRect">
             <a:avLst/>
           </a:prstGeom>
           <a:solidFill>
-            <a:srgbClr val="FFFFFF"/>
+            <a:srgbClr val="F8FAFC"/>
           </a:solidFill>
           <a:ln w="12700">
             <a:solidFill>
-              <a:srgbClr val="6E9AD6"/>
+              <a:srgbClr val="E2E8F0"/>
             </a:solidFill>
           </a:ln>
         </p:spPr>
@@ -6170,7 +6170,7 @@
               </a:spcAft>
               <a:defRPr sz="3000">
                 <a:solidFill>
-                  <a:srgbClr val="0F172A"/>
+                  <a:srgbClr val="1E293B"/>
                 </a:solidFill>
                 <a:latin typeface="Segoe UI"/>
               </a:defRPr>
@@ -6186,7 +6186,7 @@
               </a:spcAft>
               <a:defRPr sz="3000">
                 <a:solidFill>
-                  <a:srgbClr val="0F172A"/>
+                  <a:srgbClr val="1E293B"/>
                 </a:solidFill>
                 <a:latin typeface="Segoe UI"/>
               </a:defRPr>
@@ -6202,7 +6202,7 @@
               </a:spcAft>
               <a:defRPr sz="3000">
                 <a:solidFill>
-                  <a:srgbClr val="0F172A"/>
+                  <a:srgbClr val="1E293B"/>
                 </a:solidFill>
                 <a:latin typeface="Segoe UI"/>
               </a:defRPr>

</xml_diff>